<commit_message>
Polish the lab bot, voices, offline cache, and studio.
Keep the bot off footer content and modal actions, speak with three Piper voices plus a device fallback, brand the downloads, and open a clickable studio floor.

Co-authored-by: CYPHER0X9 <cipher0x9@users.noreply.github.com>
</commit_message>
<xml_diff>
--- a/downloads/modules/Python-Lab_Level-00_First-Program_Slides.pptx
+++ b/downloads/modules/Python-Lab_Level-00_First-Program_Slides.pptx
@@ -4596,6 +4596,63 @@
           </a:p>
         </p:txBody>
       </p:sp>
+      <p:pic>
+        <p:nvPicPr>
+          <p:cNvPr id="28" name="cm-brand" descr=".brand-monkey.png"/>
+          <p:cNvPicPr>
+            <a:picLocks noChangeAspect="1"/>
+          </p:cNvPicPr>
+          <p:nvPr/>
+        </p:nvPicPr>
+        <p:blipFill>
+          <a:blip r:embed="rId3"/>
+          <a:stretch>
+            <a:fillRect/>
+          </a:stretch>
+        </p:blipFill>
+        <p:spPr>
+          <a:xfrm>
+            <a:off x="10972525" y="6343650"/>
+            <a:ext cx="341367" cy="341367"/>
+          </a:xfrm>
+          <a:prstGeom prst="rect">
+            <a:avLst/>
+          </a:prstGeom>
+        </p:spPr>
+      </p:pic>
+      <p:sp>
+        <p:nvSpPr>
+          <p:cNvPr id="29" name="cm-brand-text"/>
+          <p:cNvSpPr txBox="1"/>
+          <p:nvPr/>
+        </p:nvSpPr>
+        <p:spPr>
+          <a:xfrm>
+            <a:off x="8290352" y="6377940"/>
+            <a:ext cx="2560255" cy="274320"/>
+          </a:xfrm>
+          <a:prstGeom prst="rect">
+            <a:avLst/>
+          </a:prstGeom>
+          <a:noFill/>
+        </p:spPr>
+        <p:txBody>
+          <a:bodyPr wrap="none">
+            <a:spAutoFit/>
+          </a:bodyPr>
+          <a:lstStyle/>
+          <a:p>
+            <a:r>
+              <a:rPr sz="1100" b="1">
+                <a:solidFill>
+                  <a:srgbClr val="FFFAF0"/>
+                </a:solidFill>
+              </a:rPr>
+              <a:t>cyphermonkeylabs.com</a:t>
+            </a:r>
+          </a:p>
+        </p:txBody>
+      </p:sp>
     </p:spTree>
   </p:cSld>
   <p:clrMapOvr>
@@ -5214,6 +5271,63 @@
           </a:p>
         </p:txBody>
       </p:sp>
+      <p:pic>
+        <p:nvPicPr>
+          <p:cNvPr id="14" name="cm-brand" descr=".brand-monkey.png"/>
+          <p:cNvPicPr>
+            <a:picLocks noChangeAspect="1"/>
+          </p:cNvPicPr>
+          <p:nvPr/>
+        </p:nvPicPr>
+        <p:blipFill>
+          <a:blip r:embed="rId2"/>
+          <a:stretch>
+            <a:fillRect/>
+          </a:stretch>
+        </p:blipFill>
+        <p:spPr>
+          <a:xfrm>
+            <a:off x="10972525" y="6343650"/>
+            <a:ext cx="341367" cy="341367"/>
+          </a:xfrm>
+          <a:prstGeom prst="rect">
+            <a:avLst/>
+          </a:prstGeom>
+        </p:spPr>
+      </p:pic>
+      <p:sp>
+        <p:nvSpPr>
+          <p:cNvPr id="15" name="cm-brand-text"/>
+          <p:cNvSpPr txBox="1"/>
+          <p:nvPr/>
+        </p:nvSpPr>
+        <p:spPr>
+          <a:xfrm>
+            <a:off x="8290352" y="6377940"/>
+            <a:ext cx="2560255" cy="274320"/>
+          </a:xfrm>
+          <a:prstGeom prst="rect">
+            <a:avLst/>
+          </a:prstGeom>
+          <a:noFill/>
+        </p:spPr>
+        <p:txBody>
+          <a:bodyPr wrap="none">
+            <a:spAutoFit/>
+          </a:bodyPr>
+          <a:lstStyle/>
+          <a:p>
+            <a:r>
+              <a:rPr sz="1100" b="1">
+                <a:solidFill>
+                  <a:srgbClr val="FFFAF0"/>
+                </a:solidFill>
+              </a:rPr>
+              <a:t>cyphermonkeylabs.com</a:t>
+            </a:r>
+          </a:p>
+        </p:txBody>
+      </p:sp>
     </p:spTree>
   </p:cSld>
   <p:clrMapOvr>
@@ -5976,6 +6090,63 @@
           </a:p>
         </p:txBody>
       </p:sp>
+      <p:pic>
+        <p:nvPicPr>
+          <p:cNvPr id="16" name="cm-brand" descr=".brand-monkey.png"/>
+          <p:cNvPicPr>
+            <a:picLocks noChangeAspect="1"/>
+          </p:cNvPicPr>
+          <p:nvPr/>
+        </p:nvPicPr>
+        <p:blipFill>
+          <a:blip r:embed="rId2"/>
+          <a:stretch>
+            <a:fillRect/>
+          </a:stretch>
+        </p:blipFill>
+        <p:spPr>
+          <a:xfrm>
+            <a:off x="10972525" y="6343650"/>
+            <a:ext cx="341367" cy="341367"/>
+          </a:xfrm>
+          <a:prstGeom prst="rect">
+            <a:avLst/>
+          </a:prstGeom>
+        </p:spPr>
+      </p:pic>
+      <p:sp>
+        <p:nvSpPr>
+          <p:cNvPr id="17" name="cm-brand-text"/>
+          <p:cNvSpPr txBox="1"/>
+          <p:nvPr/>
+        </p:nvSpPr>
+        <p:spPr>
+          <a:xfrm>
+            <a:off x="8290352" y="6377940"/>
+            <a:ext cx="2560255" cy="274320"/>
+          </a:xfrm>
+          <a:prstGeom prst="rect">
+            <a:avLst/>
+          </a:prstGeom>
+          <a:noFill/>
+        </p:spPr>
+        <p:txBody>
+          <a:bodyPr wrap="none">
+            <a:spAutoFit/>
+          </a:bodyPr>
+          <a:lstStyle/>
+          <a:p>
+            <a:r>
+              <a:rPr sz="1100" b="1">
+                <a:solidFill>
+                  <a:srgbClr val="FFFAF0"/>
+                </a:solidFill>
+              </a:rPr>
+              <a:t>cyphermonkeylabs.com</a:t>
+            </a:r>
+          </a:p>
+        </p:txBody>
+      </p:sp>
     </p:spTree>
   </p:cSld>
   <p:clrMapOvr>
@@ -6814,6 +6985,63 @@
           </a:p>
         </p:txBody>
       </p:sp>
+      <p:pic>
+        <p:nvPicPr>
+          <p:cNvPr id="17" name="cm-brand" descr=".brand-monkey.png"/>
+          <p:cNvPicPr>
+            <a:picLocks noChangeAspect="1"/>
+          </p:cNvPicPr>
+          <p:nvPr/>
+        </p:nvPicPr>
+        <p:blipFill>
+          <a:blip r:embed="rId2"/>
+          <a:stretch>
+            <a:fillRect/>
+          </a:stretch>
+        </p:blipFill>
+        <p:spPr>
+          <a:xfrm>
+            <a:off x="10972525" y="6343650"/>
+            <a:ext cx="341367" cy="341367"/>
+          </a:xfrm>
+          <a:prstGeom prst="rect">
+            <a:avLst/>
+          </a:prstGeom>
+        </p:spPr>
+      </p:pic>
+      <p:sp>
+        <p:nvSpPr>
+          <p:cNvPr id="18" name="cm-brand-text"/>
+          <p:cNvSpPr txBox="1"/>
+          <p:nvPr/>
+        </p:nvSpPr>
+        <p:spPr>
+          <a:xfrm>
+            <a:off x="8290352" y="6377940"/>
+            <a:ext cx="2560255" cy="274320"/>
+          </a:xfrm>
+          <a:prstGeom prst="rect">
+            <a:avLst/>
+          </a:prstGeom>
+          <a:noFill/>
+        </p:spPr>
+        <p:txBody>
+          <a:bodyPr wrap="none">
+            <a:spAutoFit/>
+          </a:bodyPr>
+          <a:lstStyle/>
+          <a:p>
+            <a:r>
+              <a:rPr sz="1100" b="1">
+                <a:solidFill>
+                  <a:srgbClr val="FFFAF0"/>
+                </a:solidFill>
+              </a:rPr>
+              <a:t>cyphermonkeylabs.com</a:t>
+            </a:r>
+          </a:p>
+        </p:txBody>
+      </p:sp>
     </p:spTree>
   </p:cSld>
   <p:clrMapOvr>
@@ -7741,6 +7969,63 @@
           </a:p>
         </p:txBody>
       </p:sp>
+      <p:pic>
+        <p:nvPicPr>
+          <p:cNvPr id="19" name="cm-brand" descr=".brand-monkey.png"/>
+          <p:cNvPicPr>
+            <a:picLocks noChangeAspect="1"/>
+          </p:cNvPicPr>
+          <p:nvPr/>
+        </p:nvPicPr>
+        <p:blipFill>
+          <a:blip r:embed="rId2"/>
+          <a:stretch>
+            <a:fillRect/>
+          </a:stretch>
+        </p:blipFill>
+        <p:spPr>
+          <a:xfrm>
+            <a:off x="10972525" y="6343650"/>
+            <a:ext cx="341367" cy="341367"/>
+          </a:xfrm>
+          <a:prstGeom prst="rect">
+            <a:avLst/>
+          </a:prstGeom>
+        </p:spPr>
+      </p:pic>
+      <p:sp>
+        <p:nvSpPr>
+          <p:cNvPr id="20" name="cm-brand-text"/>
+          <p:cNvSpPr txBox="1"/>
+          <p:nvPr/>
+        </p:nvSpPr>
+        <p:spPr>
+          <a:xfrm>
+            <a:off x="8290352" y="6377940"/>
+            <a:ext cx="2560255" cy="274320"/>
+          </a:xfrm>
+          <a:prstGeom prst="rect">
+            <a:avLst/>
+          </a:prstGeom>
+          <a:noFill/>
+        </p:spPr>
+        <p:txBody>
+          <a:bodyPr wrap="none">
+            <a:spAutoFit/>
+          </a:bodyPr>
+          <a:lstStyle/>
+          <a:p>
+            <a:r>
+              <a:rPr sz="1100" b="1">
+                <a:solidFill>
+                  <a:srgbClr val="FFFAF0"/>
+                </a:solidFill>
+              </a:rPr>
+              <a:t>cyphermonkeylabs.com</a:t>
+            </a:r>
+          </a:p>
+        </p:txBody>
+      </p:sp>
     </p:spTree>
   </p:cSld>
   <p:clrMapOvr>
@@ -8503,6 +8788,63 @@
           </a:p>
         </p:txBody>
       </p:sp>
+      <p:pic>
+        <p:nvPicPr>
+          <p:cNvPr id="16" name="cm-brand" descr=".brand-monkey.png"/>
+          <p:cNvPicPr>
+            <a:picLocks noChangeAspect="1"/>
+          </p:cNvPicPr>
+          <p:nvPr/>
+        </p:nvPicPr>
+        <p:blipFill>
+          <a:blip r:embed="rId2"/>
+          <a:stretch>
+            <a:fillRect/>
+          </a:stretch>
+        </p:blipFill>
+        <p:spPr>
+          <a:xfrm>
+            <a:off x="10972525" y="6343650"/>
+            <a:ext cx="341367" cy="341367"/>
+          </a:xfrm>
+          <a:prstGeom prst="rect">
+            <a:avLst/>
+          </a:prstGeom>
+        </p:spPr>
+      </p:pic>
+      <p:sp>
+        <p:nvSpPr>
+          <p:cNvPr id="17" name="cm-brand-text"/>
+          <p:cNvSpPr txBox="1"/>
+          <p:nvPr/>
+        </p:nvSpPr>
+        <p:spPr>
+          <a:xfrm>
+            <a:off x="8290352" y="6377940"/>
+            <a:ext cx="2560255" cy="274320"/>
+          </a:xfrm>
+          <a:prstGeom prst="rect">
+            <a:avLst/>
+          </a:prstGeom>
+          <a:noFill/>
+        </p:spPr>
+        <p:txBody>
+          <a:bodyPr wrap="none">
+            <a:spAutoFit/>
+          </a:bodyPr>
+          <a:lstStyle/>
+          <a:p>
+            <a:r>
+              <a:rPr sz="1100" b="1">
+                <a:solidFill>
+                  <a:srgbClr val="FFFAF0"/>
+                </a:solidFill>
+              </a:rPr>
+              <a:t>cyphermonkeylabs.com</a:t>
+            </a:r>
+          </a:p>
+        </p:txBody>
+      </p:sp>
     </p:spTree>
   </p:cSld>
   <p:clrMapOvr>
@@ -9550,6 +9892,63 @@
           </a:p>
         </p:txBody>
       </p:sp>
+      <p:pic>
+        <p:nvPicPr>
+          <p:cNvPr id="20" name="cm-brand" descr=".brand-monkey.png"/>
+          <p:cNvPicPr>
+            <a:picLocks noChangeAspect="1"/>
+          </p:cNvPicPr>
+          <p:nvPr/>
+        </p:nvPicPr>
+        <p:blipFill>
+          <a:blip r:embed="rId2"/>
+          <a:stretch>
+            <a:fillRect/>
+          </a:stretch>
+        </p:blipFill>
+        <p:spPr>
+          <a:xfrm>
+            <a:off x="10972525" y="6343650"/>
+            <a:ext cx="341367" cy="341367"/>
+          </a:xfrm>
+          <a:prstGeom prst="rect">
+            <a:avLst/>
+          </a:prstGeom>
+        </p:spPr>
+      </p:pic>
+      <p:sp>
+        <p:nvSpPr>
+          <p:cNvPr id="21" name="cm-brand-text"/>
+          <p:cNvSpPr txBox="1"/>
+          <p:nvPr/>
+        </p:nvSpPr>
+        <p:spPr>
+          <a:xfrm>
+            <a:off x="8290352" y="6377940"/>
+            <a:ext cx="2560255" cy="274320"/>
+          </a:xfrm>
+          <a:prstGeom prst="rect">
+            <a:avLst/>
+          </a:prstGeom>
+          <a:noFill/>
+        </p:spPr>
+        <p:txBody>
+          <a:bodyPr wrap="none">
+            <a:spAutoFit/>
+          </a:bodyPr>
+          <a:lstStyle/>
+          <a:p>
+            <a:r>
+              <a:rPr sz="1100" b="1">
+                <a:solidFill>
+                  <a:srgbClr val="FFFAF0"/>
+                </a:solidFill>
+              </a:rPr>
+              <a:t>cyphermonkeylabs.com</a:t>
+            </a:r>
+          </a:p>
+        </p:txBody>
+      </p:sp>
     </p:spTree>
   </p:cSld>
   <p:clrMapOvr>
@@ -10733,6 +11132,63 @@
           </a:p>
         </p:txBody>
       </p:sp>
+      <p:pic>
+        <p:nvPicPr>
+          <p:cNvPr id="25" name="cm-brand" descr=".brand-monkey.png"/>
+          <p:cNvPicPr>
+            <a:picLocks noChangeAspect="1"/>
+          </p:cNvPicPr>
+          <p:nvPr/>
+        </p:nvPicPr>
+        <p:blipFill>
+          <a:blip r:embed="rId2"/>
+          <a:stretch>
+            <a:fillRect/>
+          </a:stretch>
+        </p:blipFill>
+        <p:spPr>
+          <a:xfrm>
+            <a:off x="10972525" y="6343650"/>
+            <a:ext cx="341367" cy="341367"/>
+          </a:xfrm>
+          <a:prstGeom prst="rect">
+            <a:avLst/>
+          </a:prstGeom>
+        </p:spPr>
+      </p:pic>
+      <p:sp>
+        <p:nvSpPr>
+          <p:cNvPr id="26" name="cm-brand-text"/>
+          <p:cNvSpPr txBox="1"/>
+          <p:nvPr/>
+        </p:nvSpPr>
+        <p:spPr>
+          <a:xfrm>
+            <a:off x="8290352" y="6377940"/>
+            <a:ext cx="2560255" cy="274320"/>
+          </a:xfrm>
+          <a:prstGeom prst="rect">
+            <a:avLst/>
+          </a:prstGeom>
+          <a:noFill/>
+        </p:spPr>
+        <p:txBody>
+          <a:bodyPr wrap="none">
+            <a:spAutoFit/>
+          </a:bodyPr>
+          <a:lstStyle/>
+          <a:p>
+            <a:r>
+              <a:rPr sz="1100" b="1">
+                <a:solidFill>
+                  <a:srgbClr val="FFFAF0"/>
+                </a:solidFill>
+              </a:rPr>
+              <a:t>cyphermonkeylabs.com</a:t>
+            </a:r>
+          </a:p>
+        </p:txBody>
+      </p:sp>
     </p:spTree>
   </p:cSld>
   <p:clrMapOvr>
@@ -11495,6 +11951,63 @@
           </a:p>
         </p:txBody>
       </p:sp>
+      <p:pic>
+        <p:nvPicPr>
+          <p:cNvPr id="16" name="cm-brand" descr=".brand-monkey.png"/>
+          <p:cNvPicPr>
+            <a:picLocks noChangeAspect="1"/>
+          </p:cNvPicPr>
+          <p:nvPr/>
+        </p:nvPicPr>
+        <p:blipFill>
+          <a:blip r:embed="rId2"/>
+          <a:stretch>
+            <a:fillRect/>
+          </a:stretch>
+        </p:blipFill>
+        <p:spPr>
+          <a:xfrm>
+            <a:off x="10972525" y="6343650"/>
+            <a:ext cx="341367" cy="341367"/>
+          </a:xfrm>
+          <a:prstGeom prst="rect">
+            <a:avLst/>
+          </a:prstGeom>
+        </p:spPr>
+      </p:pic>
+      <p:sp>
+        <p:nvSpPr>
+          <p:cNvPr id="17" name="cm-brand-text"/>
+          <p:cNvSpPr txBox="1"/>
+          <p:nvPr/>
+        </p:nvSpPr>
+        <p:spPr>
+          <a:xfrm>
+            <a:off x="8290352" y="6377940"/>
+            <a:ext cx="2560255" cy="274320"/>
+          </a:xfrm>
+          <a:prstGeom prst="rect">
+            <a:avLst/>
+          </a:prstGeom>
+          <a:noFill/>
+        </p:spPr>
+        <p:txBody>
+          <a:bodyPr wrap="none">
+            <a:spAutoFit/>
+          </a:bodyPr>
+          <a:lstStyle/>
+          <a:p>
+            <a:r>
+              <a:rPr sz="1100" b="1">
+                <a:solidFill>
+                  <a:srgbClr val="FFFAF0"/>
+                </a:solidFill>
+              </a:rPr>
+              <a:t>cyphermonkeylabs.com</a:t>
+            </a:r>
+          </a:p>
+        </p:txBody>
+      </p:sp>
     </p:spTree>
   </p:cSld>
   <p:clrMapOvr>
@@ -12219,6 +12732,63 @@
           </a:p>
         </p:txBody>
       </p:sp>
+      <p:pic>
+        <p:nvPicPr>
+          <p:cNvPr id="16" name="cm-brand" descr=".brand-monkey.png"/>
+          <p:cNvPicPr>
+            <a:picLocks noChangeAspect="1"/>
+          </p:cNvPicPr>
+          <p:nvPr/>
+        </p:nvPicPr>
+        <p:blipFill>
+          <a:blip r:embed="rId2"/>
+          <a:stretch>
+            <a:fillRect/>
+          </a:stretch>
+        </p:blipFill>
+        <p:spPr>
+          <a:xfrm>
+            <a:off x="10972525" y="6343650"/>
+            <a:ext cx="341367" cy="341367"/>
+          </a:xfrm>
+          <a:prstGeom prst="rect">
+            <a:avLst/>
+          </a:prstGeom>
+        </p:spPr>
+      </p:pic>
+      <p:sp>
+        <p:nvSpPr>
+          <p:cNvPr id="17" name="cm-brand-text"/>
+          <p:cNvSpPr txBox="1"/>
+          <p:nvPr/>
+        </p:nvSpPr>
+        <p:spPr>
+          <a:xfrm>
+            <a:off x="8290352" y="6377940"/>
+            <a:ext cx="2560255" cy="274320"/>
+          </a:xfrm>
+          <a:prstGeom prst="rect">
+            <a:avLst/>
+          </a:prstGeom>
+          <a:noFill/>
+        </p:spPr>
+        <p:txBody>
+          <a:bodyPr wrap="none">
+            <a:spAutoFit/>
+          </a:bodyPr>
+          <a:lstStyle/>
+          <a:p>
+            <a:r>
+              <a:rPr sz="1100" b="1">
+                <a:solidFill>
+                  <a:srgbClr val="FFFAF0"/>
+                </a:solidFill>
+              </a:rPr>
+              <a:t>cyphermonkeylabs.com</a:t>
+            </a:r>
+          </a:p>
+        </p:txBody>
+      </p:sp>
     </p:spTree>
   </p:cSld>
   <p:clrMapOvr>
@@ -13038,6 +13608,63 @@
           </a:p>
         </p:txBody>
       </p:sp>
+      <p:pic>
+        <p:nvPicPr>
+          <p:cNvPr id="17" name="cm-brand" descr=".brand-monkey.png"/>
+          <p:cNvPicPr>
+            <a:picLocks noChangeAspect="1"/>
+          </p:cNvPicPr>
+          <p:nvPr/>
+        </p:nvPicPr>
+        <p:blipFill>
+          <a:blip r:embed="rId2"/>
+          <a:stretch>
+            <a:fillRect/>
+          </a:stretch>
+        </p:blipFill>
+        <p:spPr>
+          <a:xfrm>
+            <a:off x="10972525" y="6343650"/>
+            <a:ext cx="341367" cy="341367"/>
+          </a:xfrm>
+          <a:prstGeom prst="rect">
+            <a:avLst/>
+          </a:prstGeom>
+        </p:spPr>
+      </p:pic>
+      <p:sp>
+        <p:nvSpPr>
+          <p:cNvPr id="18" name="cm-brand-text"/>
+          <p:cNvSpPr txBox="1"/>
+          <p:nvPr/>
+        </p:nvSpPr>
+        <p:spPr>
+          <a:xfrm>
+            <a:off x="8290352" y="6377940"/>
+            <a:ext cx="2560255" cy="274320"/>
+          </a:xfrm>
+          <a:prstGeom prst="rect">
+            <a:avLst/>
+          </a:prstGeom>
+          <a:noFill/>
+        </p:spPr>
+        <p:txBody>
+          <a:bodyPr wrap="none">
+            <a:spAutoFit/>
+          </a:bodyPr>
+          <a:lstStyle/>
+          <a:p>
+            <a:r>
+              <a:rPr sz="1100" b="1">
+                <a:solidFill>
+                  <a:srgbClr val="FFFAF0"/>
+                </a:solidFill>
+              </a:rPr>
+              <a:t>cyphermonkeylabs.com</a:t>
+            </a:r>
+          </a:p>
+        </p:txBody>
+      </p:sp>
     </p:spTree>
   </p:cSld>
   <p:clrMapOvr>
@@ -13781,6 +14408,63 @@
           </a:p>
         </p:txBody>
       </p:sp>
+      <p:pic>
+        <p:nvPicPr>
+          <p:cNvPr id="16" name="cm-brand" descr=".brand-monkey.png"/>
+          <p:cNvPicPr>
+            <a:picLocks noChangeAspect="1"/>
+          </p:cNvPicPr>
+          <p:nvPr/>
+        </p:nvPicPr>
+        <p:blipFill>
+          <a:blip r:embed="rId2"/>
+          <a:stretch>
+            <a:fillRect/>
+          </a:stretch>
+        </p:blipFill>
+        <p:spPr>
+          <a:xfrm>
+            <a:off x="10972525" y="6343650"/>
+            <a:ext cx="341367" cy="341367"/>
+          </a:xfrm>
+          <a:prstGeom prst="rect">
+            <a:avLst/>
+          </a:prstGeom>
+        </p:spPr>
+      </p:pic>
+      <p:sp>
+        <p:nvSpPr>
+          <p:cNvPr id="17" name="cm-brand-text"/>
+          <p:cNvSpPr txBox="1"/>
+          <p:nvPr/>
+        </p:nvSpPr>
+        <p:spPr>
+          <a:xfrm>
+            <a:off x="8290352" y="6377940"/>
+            <a:ext cx="2560255" cy="274320"/>
+          </a:xfrm>
+          <a:prstGeom prst="rect">
+            <a:avLst/>
+          </a:prstGeom>
+          <a:noFill/>
+        </p:spPr>
+        <p:txBody>
+          <a:bodyPr wrap="none">
+            <a:spAutoFit/>
+          </a:bodyPr>
+          <a:lstStyle/>
+          <a:p>
+            <a:r>
+              <a:rPr sz="1100" b="1">
+                <a:solidFill>
+                  <a:srgbClr val="FFFAF0"/>
+                </a:solidFill>
+              </a:rPr>
+              <a:t>cyphermonkeylabs.com</a:t>
+            </a:r>
+          </a:p>
+        </p:txBody>
+      </p:sp>
     </p:spTree>
   </p:cSld>
   <p:clrMapOvr>
@@ -14600,6 +15284,63 @@
           </a:p>
         </p:txBody>
       </p:sp>
+      <p:pic>
+        <p:nvPicPr>
+          <p:cNvPr id="17" name="cm-brand" descr=".brand-monkey.png"/>
+          <p:cNvPicPr>
+            <a:picLocks noChangeAspect="1"/>
+          </p:cNvPicPr>
+          <p:nvPr/>
+        </p:nvPicPr>
+        <p:blipFill>
+          <a:blip r:embed="rId2"/>
+          <a:stretch>
+            <a:fillRect/>
+          </a:stretch>
+        </p:blipFill>
+        <p:spPr>
+          <a:xfrm>
+            <a:off x="10972525" y="6343650"/>
+            <a:ext cx="341367" cy="341367"/>
+          </a:xfrm>
+          <a:prstGeom prst="rect">
+            <a:avLst/>
+          </a:prstGeom>
+        </p:spPr>
+      </p:pic>
+      <p:sp>
+        <p:nvSpPr>
+          <p:cNvPr id="18" name="cm-brand-text"/>
+          <p:cNvSpPr txBox="1"/>
+          <p:nvPr/>
+        </p:nvSpPr>
+        <p:spPr>
+          <a:xfrm>
+            <a:off x="8290352" y="6377940"/>
+            <a:ext cx="2560255" cy="274320"/>
+          </a:xfrm>
+          <a:prstGeom prst="rect">
+            <a:avLst/>
+          </a:prstGeom>
+          <a:noFill/>
+        </p:spPr>
+        <p:txBody>
+          <a:bodyPr wrap="none">
+            <a:spAutoFit/>
+          </a:bodyPr>
+          <a:lstStyle/>
+          <a:p>
+            <a:r>
+              <a:rPr sz="1100" b="1">
+                <a:solidFill>
+                  <a:srgbClr val="FFFAF0"/>
+                </a:solidFill>
+              </a:rPr>
+              <a:t>cyphermonkeylabs.com</a:t>
+            </a:r>
+          </a:p>
+        </p:txBody>
+      </p:sp>
     </p:spTree>
   </p:cSld>
   <p:clrMapOvr>
@@ -15527,6 +16268,63 @@
           </a:p>
         </p:txBody>
       </p:sp>
+      <p:pic>
+        <p:nvPicPr>
+          <p:cNvPr id="19" name="cm-brand" descr=".brand-monkey.png"/>
+          <p:cNvPicPr>
+            <a:picLocks noChangeAspect="1"/>
+          </p:cNvPicPr>
+          <p:nvPr/>
+        </p:nvPicPr>
+        <p:blipFill>
+          <a:blip r:embed="rId2"/>
+          <a:stretch>
+            <a:fillRect/>
+          </a:stretch>
+        </p:blipFill>
+        <p:spPr>
+          <a:xfrm>
+            <a:off x="10972525" y="6343650"/>
+            <a:ext cx="341367" cy="341367"/>
+          </a:xfrm>
+          <a:prstGeom prst="rect">
+            <a:avLst/>
+          </a:prstGeom>
+        </p:spPr>
+      </p:pic>
+      <p:sp>
+        <p:nvSpPr>
+          <p:cNvPr id="20" name="cm-brand-text"/>
+          <p:cNvSpPr txBox="1"/>
+          <p:nvPr/>
+        </p:nvSpPr>
+        <p:spPr>
+          <a:xfrm>
+            <a:off x="8290352" y="6377940"/>
+            <a:ext cx="2560255" cy="274320"/>
+          </a:xfrm>
+          <a:prstGeom prst="rect">
+            <a:avLst/>
+          </a:prstGeom>
+          <a:noFill/>
+        </p:spPr>
+        <p:txBody>
+          <a:bodyPr wrap="none">
+            <a:spAutoFit/>
+          </a:bodyPr>
+          <a:lstStyle/>
+          <a:p>
+            <a:r>
+              <a:rPr sz="1100" b="1">
+                <a:solidFill>
+                  <a:srgbClr val="FFFAF0"/>
+                </a:solidFill>
+              </a:rPr>
+              <a:t>cyphermonkeylabs.com</a:t>
+            </a:r>
+          </a:p>
+        </p:txBody>
+      </p:sp>
     </p:spTree>
   </p:cSld>
   <p:clrMapOvr>
@@ -16137,6 +16935,63 @@
                 <a:latin typeface="Consolas"/>
               </a:rPr>
               <a:t>    print("NameError:", err)</a:t>
+            </a:r>
+          </a:p>
+        </p:txBody>
+      </p:sp>
+      <p:pic>
+        <p:nvPicPr>
+          <p:cNvPr id="13" name="cm-brand" descr=".brand-monkey.png"/>
+          <p:cNvPicPr>
+            <a:picLocks noChangeAspect="1"/>
+          </p:cNvPicPr>
+          <p:nvPr/>
+        </p:nvPicPr>
+        <p:blipFill>
+          <a:blip r:embed="rId2"/>
+          <a:stretch>
+            <a:fillRect/>
+          </a:stretch>
+        </p:blipFill>
+        <p:spPr>
+          <a:xfrm>
+            <a:off x="10972525" y="6343650"/>
+            <a:ext cx="341367" cy="341367"/>
+          </a:xfrm>
+          <a:prstGeom prst="rect">
+            <a:avLst/>
+          </a:prstGeom>
+        </p:spPr>
+      </p:pic>
+      <p:sp>
+        <p:nvSpPr>
+          <p:cNvPr id="14" name="cm-brand-text"/>
+          <p:cNvSpPr txBox="1"/>
+          <p:nvPr/>
+        </p:nvSpPr>
+        <p:spPr>
+          <a:xfrm>
+            <a:off x="8290352" y="6377940"/>
+            <a:ext cx="2560255" cy="274320"/>
+          </a:xfrm>
+          <a:prstGeom prst="rect">
+            <a:avLst/>
+          </a:prstGeom>
+          <a:noFill/>
+        </p:spPr>
+        <p:txBody>
+          <a:bodyPr wrap="none">
+            <a:spAutoFit/>
+          </a:bodyPr>
+          <a:lstStyle/>
+          <a:p>
+            <a:r>
+              <a:rPr sz="1100" b="1">
+                <a:solidFill>
+                  <a:srgbClr val="FFFAF0"/>
+                </a:solidFill>
+              </a:rPr>
+              <a:t>cyphermonkeylabs.com</a:t>
             </a:r>
           </a:p>
         </p:txBody>

</xml_diff>